<commit_message>
docs(slides): update financial agent deck
</commit_message>
<xml_diff>
--- a/entregables/presentacion/agente-riesgo-financiero.pptx
+++ b/entregables/presentacion/agente-riesgo-financiero.pptx
@@ -2,17 +2,17 @@
 <file path=ppt/presentation.xml><?xml version="1.0" encoding="utf-8"?>
 <p:presentation xmlns:p="http://schemas.openxmlformats.org/presentationml/2006/main">
   <p:sldMasterIdLst>
-    <p:sldMasterId xmlns:r="http://schemas.openxmlformats.org/officeDocument/2006/relationships" id="2147483648" r:id="R99dcb89d87db49be"/>
+    <p:sldMasterId xmlns:r="http://schemas.openxmlformats.org/officeDocument/2006/relationships" id="2147483648" r:id="R1dbc773edaf54a15"/>
   </p:sldMasterIdLst>
   <p:notesMasterIdLst>
-    <p:notesMasterId xmlns:r="http://schemas.openxmlformats.org/officeDocument/2006/relationships" r:id="R208a1225d77f4bd2"/>
+    <p:notesMasterId xmlns:r="http://schemas.openxmlformats.org/officeDocument/2006/relationships" r:id="R0f9c3326ee494d4e"/>
   </p:notesMasterIdLst>
   <p:sldIdLst>
-    <p:sldId xmlns:r="http://schemas.openxmlformats.org/officeDocument/2006/relationships" id="256" r:id="Racaf501f401c47e3"/>
-    <p:sldId xmlns:r="http://schemas.openxmlformats.org/officeDocument/2006/relationships" id="257" r:id="R43d7a69a2ee4457b"/>
-    <p:sldId xmlns:r="http://schemas.openxmlformats.org/officeDocument/2006/relationships" id="258" r:id="R060290b6458946a5"/>
-    <p:sldId xmlns:r="http://schemas.openxmlformats.org/officeDocument/2006/relationships" id="259" r:id="R0623f390035242a2"/>
-    <p:sldId xmlns:r="http://schemas.openxmlformats.org/officeDocument/2006/relationships" id="260" r:id="Rea83609c547142c6"/>
+    <p:sldId xmlns:r="http://schemas.openxmlformats.org/officeDocument/2006/relationships" id="256" r:id="R986d04b0a231469e"/>
+    <p:sldId xmlns:r="http://schemas.openxmlformats.org/officeDocument/2006/relationships" id="257" r:id="Rcfade135be474024"/>
+    <p:sldId xmlns:r="http://schemas.openxmlformats.org/officeDocument/2006/relationships" id="258" r:id="R60cb0feca6c84f57"/>
+    <p:sldId xmlns:r="http://schemas.openxmlformats.org/officeDocument/2006/relationships" id="259" r:id="R957cc9d1f1d34de8"/>
+    <p:sldId xmlns:r="http://schemas.openxmlformats.org/officeDocument/2006/relationships" id="260" r:id="R60c1fdd90d3c4af5"/>
   </p:sldIdLst>
   <p:sldSz cx="12192000" cy="6858000"/>
   <p:notesSz cx="6858000" cy="9144000"/>
@@ -446,27 +446,7 @@
           <a:lstStyle xmlns:a="http://schemas.openxmlformats.org/drawingml/2006/main"/>
           <a:p xmlns:a="http://schemas.openxmlformats.org/drawingml/2006/main">
             <a:r>
-              <a:t>Presentamos un agente que convierte estados financieros en PDF en información útil para el análisis. La propuesta no reemplaza al contador ni al asesor: acelera la revisión inicial, calcula indicadores de forma verificable y permite consultar la evidencia del documento. Hoy mostraremos el problema, la tecnología, la arquitectura y los resultados funcionales.</a:t>
-            </a:r>
-          </a:p>
-          <a:p xmlns:a="http://schemas.openxmlformats.org/drawingml/2006/main">
-            <a:r>
-              <a:t/>
-            </a:r>
-          </a:p>
-          <a:p xmlns:a="http://schemas.openxmlformats.org/drawingml/2006/main">
-            <a:r>
-              <a:t>[Sources]</a:t>
-            </a:r>
-          </a:p>
-          <a:p xmlns:a="http://schemas.openxmlformats.org/drawingml/2006/main">
-            <a:r>
-              <a:t>- D:/Documents/agente_riesgo_financiero.pdf</a:t>
-            </a:r>
-          </a:p>
-          <a:p xmlns:a="http://schemas.openxmlformats.org/drawingml/2006/main">
-            <a:r>
-              <a:t>- Imagen de portada generada con OpenAI Image Generation para esta presentación.</a:t>
+              <a:t>RiskLens Finance analiza estados financieros en PDF y transforma sus datos en indicadores, alertas, escenarios de inversión y pronósticos. La aplicación conserva evidencia documental y trazabilidad operativa.</a:t>
             </a:r>
           </a:p>
         </p:txBody>
@@ -536,22 +516,7 @@
           <a:lstStyle xmlns:a="http://schemas.openxmlformats.org/drawingml/2006/main"/>
           <a:p xmlns:a="http://schemas.openxmlformats.org/drawingml/2006/main">
             <a:r>
-              <a:t>El problema comienza con documentos extensos y técnicos. El analista debe localizar las cifras, realizar cálculos y recordar umbrales de riesgo. Esto consume tiempo y puede ocultar una caída de ingresos, un deterioro de liquidez o un aumento del endeudamiento. La oportunidad es automatizar la lectura inicial sin perder trazabilidad: cada conclusión debe estar respaldada por un cálculo o por evidencia del PDF.</a:t>
-            </a:r>
-          </a:p>
-          <a:p xmlns:a="http://schemas.openxmlformats.org/drawingml/2006/main">
-            <a:r>
-              <a:t/>
-            </a:r>
-          </a:p>
-          <a:p xmlns:a="http://schemas.openxmlformats.org/drawingml/2006/main">
-            <a:r>
-              <a:t>[Sources]</a:t>
-            </a:r>
-          </a:p>
-          <a:p xmlns:a="http://schemas.openxmlformats.org/drawingml/2006/main">
-            <a:r>
-              <a:t>- D:/Documents/agente_riesgo_financiero.pdf, secciones 1 a 3</a:t>
+              <a:t>El agente concentra la lectura del PDF, los cálculos determinísticos y la consulta con evidencia. La versión actual añade efectivo disponible, flujo de caja, simulación financiera y pronóstico mensual de ventas.</a:t>
             </a:r>
           </a:p>
         </p:txBody>
@@ -621,32 +586,7 @@
           <a:lstStyle xmlns:a="http://schemas.openxmlformats.org/drawingml/2006/main"/>
           <a:p xmlns:a="http://schemas.openxmlformats.org/drawingml/2006/main">
             <a:r>
-              <a:t>La interfaz se construyó con Streamlit y el backend con FastAPI. LangGraph organiza el agente, mientras Gemini se utiliza para OCR, extracción estructurada, resúmenes, respuestas y embeddings. SQLite conserva usuarios, sesiones y análisis; MLflow observa cada ejecución. La seguridad combina JWT, bcrypt y autorización por roles. Un punto importante es que los ratios se calculan en Python: Gemini los interpreta, pero no inventa las fórmulas ni los valores.</a:t>
-            </a:r>
-          </a:p>
-          <a:p xmlns:a="http://schemas.openxmlformats.org/drawingml/2006/main">
-            <a:r>
-              <a:t/>
-            </a:r>
-          </a:p>
-          <a:p xmlns:a="http://schemas.openxmlformats.org/drawingml/2006/main">
-            <a:r>
-              <a:t>[Sources]</a:t>
-            </a:r>
-          </a:p>
-          <a:p xmlns:a="http://schemas.openxmlformats.org/drawingml/2006/main">
-            <a:r>
-              <a:t>- D:/Documents/agente_riesgo_financiero.pdf, secciones 5 y 6</a:t>
-            </a:r>
-          </a:p>
-          <a:p xmlns:a="http://schemas.openxmlformats.org/drawingml/2006/main">
-            <a:r>
-              <a:t>- D:/Documents/ChatGPT/Riesgo-Financiero/requirements.txt</a:t>
-            </a:r>
-          </a:p>
-          <a:p xmlns:a="http://schemas.openxmlformats.org/drawingml/2006/main">
-            <a:r>
-              <a:t>- D:/Documents/ChatGPT/Riesgo-Financiero/README.md</a:t>
+              <a:t>Streamlit presenta la experiencia y FastAPI expone la API protegida. LangGraph coordina siete nodos en dos grafos. Python ejecuta los cálculos financieros y el pronóstico temporal. Gemini participa en extracción, interpretación y explicación. MLflow registra los nodos ejecutados y su latencia sin guardar el contenido financiero.</a:t>
             </a:r>
           </a:p>
         </p:txBody>
@@ -716,37 +656,7 @@
           <a:lstStyle xmlns:a="http://schemas.openxmlformats.org/drawingml/2006/main"/>
           <a:p xmlns:a="http://schemas.openxmlformats.org/drawingml/2006/main">
             <a:r>
-              <a:t>El usuario trabaja en Streamlit y cada operación protegida viaja con un JWT hacia FastAPI. El PDF puede procesarse por extracción normal u OCR. LangGraph ejecuta cuatro nodos: extracción, cálculo, alertas y resumen. Para preguntas usamos otro grafo con RAG graduado: primero busca indicadores estructurados, luego coincidencias literales y finalmente similitud semántica. Si no existe evidencia suficiente, el flujo solicita aclaración en vez de inventar una respuesta. MLflow registra qué nodo se ejecutó y cuánto demoró.</a:t>
-            </a:r>
-          </a:p>
-          <a:p xmlns:a="http://schemas.openxmlformats.org/drawingml/2006/main">
-            <a:r>
-              <a:t/>
-            </a:r>
-          </a:p>
-          <a:p xmlns:a="http://schemas.openxmlformats.org/drawingml/2006/main">
-            <a:r>
-              <a:t>[Sources]</a:t>
-            </a:r>
-          </a:p>
-          <a:p xmlns:a="http://schemas.openxmlformats.org/drawingml/2006/main">
-            <a:r>
-              <a:t>- D:/Documents/agente_riesgo_financiero.pdf, sección 6</a:t>
-            </a:r>
-          </a:p>
-          <a:p xmlns:a="http://schemas.openxmlformats.org/drawingml/2006/main">
-            <a:r>
-              <a:t>- D:/Documents/ChatGPT/Riesgo-Financiero/backend/workflow/graph.py</a:t>
-            </a:r>
-          </a:p>
-          <a:p xmlns:a="http://schemas.openxmlformats.org/drawingml/2006/main">
-            <a:r>
-              <a:t>- D:/Documents/ChatGPT/Riesgo-Financiero/backend/workflow/state.py</a:t>
-            </a:r>
-          </a:p>
-          <a:p xmlns:a="http://schemas.openxmlformats.org/drawingml/2006/main">
-            <a:r>
-              <a:t>- D:/Documents/ChatGPT/Riesgo-Financiero/backend/agent/qa.py</a:t>
+              <a:t>El grafo de análisis ejecuta extracción, indicadores, alertas y resumen. El grafo de preguntas ejecuta recuperación y después responde o solicita aclaración. MLflow registra únicamente los nodos recorridos, su estado, campos y duración. La API exige JWT y aplica permisos de administrador y analista.</a:t>
             </a:r>
           </a:p>
         </p:txBody>
@@ -816,37 +726,7 @@
           <a:lstStyle xmlns:a="http://schemas.openxmlformats.org/drawingml/2006/main"/>
           <a:p xmlns:a="http://schemas.openxmlformats.org/drawingml/2006/main">
             <a:r>
-              <a:t>La evidencia debe mostrarse con capturas reales durante la demo: el análisis y sus alertas, el dashboard y una pregunta respondida con el fragmento recuperado. Todas las pruebas usan documentos sintéticos. El resultado es una herramienta que automatiza la revisión inicial, genera reportes y protege el acceso por roles. Como siguiente iteración proponemos comparación histórica, extracción de contingencias desde notas y una base PostgreSQL para escenarios de mayor escala.</a:t>
-            </a:r>
-          </a:p>
-          <a:p xmlns:a="http://schemas.openxmlformats.org/drawingml/2006/main">
-            <a:r>
-              <a:t/>
-            </a:r>
-          </a:p>
-          <a:p xmlns:a="http://schemas.openxmlformats.org/drawingml/2006/main">
-            <a:r>
-              <a:t>[Sources]</a:t>
-            </a:r>
-          </a:p>
-          <a:p xmlns:a="http://schemas.openxmlformats.org/drawingml/2006/main">
-            <a:r>
-              <a:t>- D:/Documents/agente_riesgo_financiero.pdf, secciones 8 a 10</a:t>
-            </a:r>
-          </a:p>
-          <a:p xmlns:a="http://schemas.openxmlformats.org/drawingml/2006/main">
-            <a:r>
-              <a:t>- D:/Documents/ChatGPT/Riesgo-Financiero/output/GUIA_PRUEBAS.md</a:t>
-            </a:r>
-          </a:p>
-          <a:p xmlns:a="http://schemas.openxmlformats.org/drawingml/2006/main">
-            <a:r>
-              <a:t>- D:/Documents/ChatGPT/Riesgo-Financiero/frontend/app.py</a:t>
-            </a:r>
-          </a:p>
-          <a:p xmlns:a="http://schemas.openxmlformats.org/drawingml/2006/main">
-            <a:r>
-              <a:t>- D:/Documents/ChatGPT/Riesgo-Financiero/frontend/dashboard.py</a:t>
+              <a:t>La demo muestra tres evidencias reales: dashboard mensual, pronóstico estadístico y observabilidad en MLflow. El pronóstico compara regresión temporal con persistencia mediante MAE y presenta un rango orientativo. El simulador convierte tasas nominales o efectivas y calcula valor futuro, VAN, TIR y recuperación. Los resultados apoyan la revisión profesional y no constituyen una recomendación de inversión.</a:t>
             </a:r>
           </a:p>
         </p:txBody>
@@ -914,7 +794,7 @@
   </p:cSld>
   <p:clrMap bg1="lt1" tx1="dk1" bg2="lt2" tx2="dk2" accent1="accent1" accent2="accent2" accent3="accent3" accent4="accent4" accent5="accent5" accent6="accent6" hlink="hlink" folHlink="folHlink"/>
   <p:sldLayoutIdLst>
-    <p:sldLayoutId xmlns:r="http://schemas.openxmlformats.org/officeDocument/2006/relationships" id="2147483649" r:id="Rcf5317fe338a424e"/>
+    <p:sldLayoutId xmlns:r="http://schemas.openxmlformats.org/officeDocument/2006/relationships" id="2147483649" r:id="R19d45e91d9764787"/>
   </p:sldLayoutIdLst>
   <p:txStyles>
     <p:titleStyle>
@@ -1462,14 +1342,14 @@
       </p:grpSpPr>
       <p:pic>
         <p:nvPicPr>
-          <p:cNvPr id="13" name=""/>
+          <p:cNvPr id="14" name=""/>
           <p:cNvPicPr>
             <a:picLocks xmlns:a="http://schemas.openxmlformats.org/drawingml/2006/main" noChangeAspect="1"/>
           </p:cNvPicPr>
           <p:nvPr/>
         </p:nvPicPr>
         <p:blipFill>
-          <a:blip xmlns:r="http://schemas.openxmlformats.org/officeDocument/2006/relationships" xmlns:a="http://schemas.openxmlformats.org/drawingml/2006/main" r:embed="R4ac8b849983e4819"/>
+          <a:blip xmlns:r="http://schemas.openxmlformats.org/officeDocument/2006/relationships" xmlns:a="http://schemas.openxmlformats.org/drawingml/2006/main" r:embed="R5dbe7d323c6740e7"/>
           <a:srcRect xmlns:a="http://schemas.openxmlformats.org/drawingml/2006/main" l="0" t="27" r="0" b="27"/>
           <a:stretch xmlns:a="http://schemas.openxmlformats.org/drawingml/2006/main">
             <a:fillRect l="0" t="0" r="0" b="0"/>
@@ -1580,6 +1460,7 @@
           <a:lstStyle xmlns:a="http://schemas.openxmlformats.org/drawingml/2006/main"/>
           <a:p xmlns:a="http://schemas.openxmlformats.org/drawingml/2006/main">
             <a:pPr algn="l">
+              <a:buNone/>
               <a:defRPr sz="1200" b="1">
                 <a:solidFill>
                   <a:srgbClr val="37D5FF"/>
@@ -1630,6 +1511,7 @@
           <a:lstStyle xmlns:a="http://schemas.openxmlformats.org/drawingml/2006/main"/>
           <a:p xmlns:a="http://schemas.openxmlformats.org/drawingml/2006/main">
             <a:pPr algn="l">
+              <a:buNone/>
               <a:defRPr sz="3900" b="1">
                 <a:solidFill>
                   <a:srgbClr val="F7FBFF"/>
@@ -1647,6 +1529,7 @@
           </a:p>
           <a:p xmlns:a="http://schemas.openxmlformats.org/drawingml/2006/main">
             <a:pPr algn="l">
+              <a:buNone/>
               <a:defRPr sz="3900" b="1">
                 <a:solidFill>
                   <a:srgbClr val="F7FBFF"/>
@@ -1697,6 +1580,7 @@
           <a:lstStyle xmlns:a="http://schemas.openxmlformats.org/drawingml/2006/main"/>
           <a:p xmlns:a="http://schemas.openxmlformats.org/drawingml/2006/main">
             <a:pPr algn="l">
+              <a:buNone/>
               <a:defRPr sz="1800" b="0">
                 <a:solidFill>
                   <a:srgbClr val="AFC5DC"/>
@@ -1714,6 +1598,7 @@
           </a:p>
           <a:p xmlns:a="http://schemas.openxmlformats.org/drawingml/2006/main">
             <a:pPr algn="l">
+              <a:buNone/>
               <a:defRPr sz="1800" b="0">
                 <a:solidFill>
                   <a:srgbClr val="AFC5DC"/>
@@ -1764,6 +1649,7 @@
           <a:lstStyle xmlns:a="http://schemas.openxmlformats.org/drawingml/2006/main"/>
           <a:p xmlns:a="http://schemas.openxmlformats.org/drawingml/2006/main">
             <a:pPr algn="l">
+              <a:buNone/>
               <a:defRPr sz="1650" b="1">
                 <a:solidFill>
                   <a:srgbClr val="F7FBFF"/>
@@ -1776,11 +1662,12 @@
                   <a:srgbClr val="F7FBFF"/>
                 </a:solidFill>
               </a:rPr>
-              <a:t>De un PDF a indicadores, alertas</a:t>
+              <a:t>De un PDF a indicadores, escenarios,</a:t>
             </a:r>
           </a:p>
           <a:p xmlns:a="http://schemas.openxmlformats.org/drawingml/2006/main">
             <a:pPr algn="l">
+              <a:buNone/>
               <a:defRPr sz="1650" b="1">
                 <a:solidFill>
                   <a:srgbClr val="F7FBFF"/>
@@ -1793,7 +1680,7 @@
                   <a:srgbClr val="F7FBFF"/>
                 </a:solidFill>
               </a:rPr>
-              <a:t>y respuestas con evidencia.</a:t>
+              <a:t>pronósticos y respuestas con evidencia.</a:t>
             </a:r>
           </a:p>
         </p:txBody>
@@ -1862,6 +1749,7 @@
           <a:lstStyle xmlns:a="http://schemas.openxmlformats.org/drawingml/2006/main"/>
           <a:p xmlns:a="http://schemas.openxmlformats.org/drawingml/2006/main">
             <a:pPr algn="l">
+              <a:buNone/>
               <a:defRPr sz="1050" b="1">
                 <a:solidFill>
                   <a:srgbClr val="AFC5DC"/>
@@ -1874,7 +1762,7 @@
                   <a:srgbClr val="AFC5DC"/>
                 </a:solidFill>
               </a:rPr>
-              <a:t>EQUIPO  [COLOCAR NOMBRES]</a:t>
+              <a:t>EQUIPO · LABORATORIO DE IA</a:t>
             </a:r>
           </a:p>
         </p:txBody>
@@ -1912,6 +1800,7 @@
           <a:lstStyle xmlns:a="http://schemas.openxmlformats.org/drawingml/2006/main"/>
           <a:p xmlns:a="http://schemas.openxmlformats.org/drawingml/2006/main">
             <a:pPr algn="l">
+              <a:buNone/>
               <a:defRPr sz="1050" b="0">
                 <a:solidFill>
                   <a:srgbClr val="AFC5DC"/>
@@ -1924,7 +1813,7 @@
                   <a:srgbClr val="AFC5DC"/>
                 </a:solidFill>
               </a:rPr>
-              <a:t>[COLOCAR FECHA]</a:t>
+              <a:t>VERSIÓN · SEPTIEMBRE 2026</a:t>
             </a:r>
           </a:p>
         </p:txBody>
@@ -1997,6 +1886,7 @@
           <a:lstStyle xmlns:a="http://schemas.openxmlformats.org/drawingml/2006/main"/>
           <a:p xmlns:a="http://schemas.openxmlformats.org/drawingml/2006/main">
             <a:pPr algn="ctr">
+              <a:buNone/>
               <a:defRPr sz="1050" b="1">
                 <a:solidFill>
                   <a:srgbClr val="071426"/>
@@ -2076,6 +1966,7 @@
           <a:lstStyle xmlns:a="http://schemas.openxmlformats.org/drawingml/2006/main"/>
           <a:p xmlns:a="http://schemas.openxmlformats.org/drawingml/2006/main">
             <a:pPr algn="l">
+              <a:buNone/>
               <a:defRPr sz="1200" b="1">
                 <a:solidFill>
                   <a:srgbClr val="168BFF"/>
@@ -2126,6 +2017,7 @@
           <a:lstStyle xmlns:a="http://schemas.openxmlformats.org/drawingml/2006/main"/>
           <a:p xmlns:a="http://schemas.openxmlformats.org/drawingml/2006/main">
             <a:pPr algn="l">
+              <a:buNone/>
               <a:defRPr sz="2850" b="1">
                 <a:solidFill>
                   <a:srgbClr val="10233B"/>
@@ -2465,6 +2357,7 @@
           <a:lstStyle xmlns:a="http://schemas.openxmlformats.org/drawingml/2006/main"/>
           <a:p xmlns:a="http://schemas.openxmlformats.org/drawingml/2006/main">
             <a:pPr algn="ctr">
+              <a:buNone/>
               <a:defRPr sz="1425" b="1">
                 <a:solidFill>
                   <a:srgbClr val="10233B"/>
@@ -2515,6 +2408,7 @@
           <a:lstStyle xmlns:a="http://schemas.openxmlformats.org/drawingml/2006/main"/>
           <a:p xmlns:a="http://schemas.openxmlformats.org/drawingml/2006/main">
             <a:pPr algn="ctr">
+              <a:buNone/>
               <a:defRPr sz="1125" b="0">
                 <a:solidFill>
                   <a:srgbClr val="5B6F87"/>
@@ -2532,6 +2426,7 @@
           </a:p>
           <a:p xmlns:a="http://schemas.openxmlformats.org/drawingml/2006/main">
             <a:pPr algn="ctr">
+              <a:buNone/>
               <a:defRPr sz="1125" b="0">
                 <a:solidFill>
                   <a:srgbClr val="5B6F87"/>
@@ -2648,6 +2543,7 @@
           <a:lstStyle xmlns:a="http://schemas.openxmlformats.org/drawingml/2006/main"/>
           <a:p xmlns:a="http://schemas.openxmlformats.org/drawingml/2006/main">
             <a:pPr algn="ctr">
+              <a:buNone/>
               <a:defRPr sz="1425" b="1">
                 <a:solidFill>
                   <a:srgbClr val="10233B"/>
@@ -2698,6 +2594,7 @@
           <a:lstStyle xmlns:a="http://schemas.openxmlformats.org/drawingml/2006/main"/>
           <a:p xmlns:a="http://schemas.openxmlformats.org/drawingml/2006/main">
             <a:pPr algn="ctr">
+              <a:buNone/>
               <a:defRPr sz="1125" b="0">
                 <a:solidFill>
                   <a:srgbClr val="5B6F87"/>
@@ -2715,6 +2612,7 @@
           </a:p>
           <a:p xmlns:a="http://schemas.openxmlformats.org/drawingml/2006/main">
             <a:pPr algn="ctr">
+              <a:buNone/>
               <a:defRPr sz="1125" b="0">
                 <a:solidFill>
                   <a:srgbClr val="5B6F87"/>
@@ -2831,6 +2729,7 @@
           <a:lstStyle xmlns:a="http://schemas.openxmlformats.org/drawingml/2006/main"/>
           <a:p xmlns:a="http://schemas.openxmlformats.org/drawingml/2006/main">
             <a:pPr algn="ctr">
+              <a:buNone/>
               <a:defRPr sz="1425" b="1">
                 <a:solidFill>
                   <a:srgbClr val="10233B"/>
@@ -2881,6 +2780,7 @@
           <a:lstStyle xmlns:a="http://schemas.openxmlformats.org/drawingml/2006/main"/>
           <a:p xmlns:a="http://schemas.openxmlformats.org/drawingml/2006/main">
             <a:pPr algn="ctr">
+              <a:buNone/>
               <a:defRPr sz="1125" b="0">
                 <a:solidFill>
                   <a:srgbClr val="5B6F87"/>
@@ -2898,6 +2798,7 @@
           </a:p>
           <a:p xmlns:a="http://schemas.openxmlformats.org/drawingml/2006/main">
             <a:pPr algn="ctr">
+              <a:buNone/>
               <a:defRPr sz="1125" b="0">
                 <a:solidFill>
                   <a:srgbClr val="5B6F87"/>
@@ -3014,6 +2915,7 @@
           <a:lstStyle xmlns:a="http://schemas.openxmlformats.org/drawingml/2006/main"/>
           <a:p xmlns:a="http://schemas.openxmlformats.org/drawingml/2006/main">
             <a:pPr algn="ctr">
+              <a:buNone/>
               <a:defRPr sz="1425" b="1">
                 <a:solidFill>
                   <a:srgbClr val="10233B"/>
@@ -3064,6 +2966,7 @@
           <a:lstStyle xmlns:a="http://schemas.openxmlformats.org/drawingml/2006/main"/>
           <a:p xmlns:a="http://schemas.openxmlformats.org/drawingml/2006/main">
             <a:pPr algn="ctr">
+              <a:buNone/>
               <a:defRPr sz="1125" b="0">
                 <a:solidFill>
                   <a:srgbClr val="5B6F87"/>
@@ -3081,6 +2984,7 @@
           </a:p>
           <a:p xmlns:a="http://schemas.openxmlformats.org/drawingml/2006/main">
             <a:pPr algn="ctr">
+              <a:buNone/>
               <a:defRPr sz="1125" b="0">
                 <a:solidFill>
                   <a:srgbClr val="5B6F87"/>
@@ -3131,6 +3035,7 @@
           <a:lstStyle xmlns:a="http://schemas.openxmlformats.org/drawingml/2006/main"/>
           <a:p xmlns:a="http://schemas.openxmlformats.org/drawingml/2006/main">
             <a:pPr algn="l">
+              <a:buNone/>
               <a:defRPr sz="1500" b="1">
                 <a:solidFill>
                   <a:srgbClr val="FF6B6B"/>
@@ -3181,6 +3086,7 @@
           <a:lstStyle xmlns:a="http://schemas.openxmlformats.org/drawingml/2006/main"/>
           <a:p xmlns:a="http://schemas.openxmlformats.org/drawingml/2006/main">
             <a:pPr algn="l">
+              <a:buNone/>
               <a:defRPr sz="1500" b="0">
                 <a:solidFill>
                   <a:srgbClr val="10233B"/>
@@ -3198,6 +3104,7 @@
           </a:p>
           <a:p xmlns:a="http://schemas.openxmlformats.org/drawingml/2006/main">
             <a:pPr algn="l">
+              <a:buNone/>
               <a:defRPr sz="1500" b="0">
                 <a:solidFill>
                   <a:srgbClr val="10233B"/>
@@ -3215,6 +3122,7 @@
           </a:p>
           <a:p xmlns:a="http://schemas.openxmlformats.org/drawingml/2006/main">
             <a:pPr algn="l">
+              <a:buNone/>
               <a:defRPr sz="1500" b="0">
                 <a:solidFill>
                   <a:srgbClr val="10233B"/>
@@ -3296,6 +3204,7 @@
           <a:lstStyle xmlns:a="http://schemas.openxmlformats.org/drawingml/2006/main"/>
           <a:p xmlns:a="http://schemas.openxmlformats.org/drawingml/2006/main">
             <a:pPr algn="l">
+              <a:buNone/>
               <a:defRPr sz="1500" b="1">
                 <a:solidFill>
                   <a:srgbClr val="26D99A"/>
@@ -3346,6 +3255,7 @@
           <a:lstStyle xmlns:a="http://schemas.openxmlformats.org/drawingml/2006/main"/>
           <a:p xmlns:a="http://schemas.openxmlformats.org/drawingml/2006/main">
             <a:pPr algn="l">
+              <a:buNone/>
               <a:defRPr sz="1500" b="0">
                 <a:solidFill>
                   <a:srgbClr val="10233B"/>
@@ -3363,6 +3273,7 @@
           </a:p>
           <a:p xmlns:a="http://schemas.openxmlformats.org/drawingml/2006/main">
             <a:pPr algn="l">
+              <a:buNone/>
               <a:defRPr sz="1500" b="0">
                 <a:solidFill>
                   <a:srgbClr val="10233B"/>
@@ -3375,11 +3286,30 @@
                   <a:srgbClr val="10233B"/>
                 </a:solidFill>
               </a:rPr>
-              <a:t>• Indicadores y alertas automáticas</a:t>
+              <a:t>• Ratios, alertas y efectivo disponible</a:t>
             </a:r>
           </a:p>
           <a:p xmlns:a="http://schemas.openxmlformats.org/drawingml/2006/main">
             <a:pPr algn="l">
+              <a:buNone/>
+              <a:defRPr sz="1500" b="0">
+                <a:solidFill>
+                  <a:srgbClr val="10233B"/>
+                </a:solidFill>
+              </a:defRPr>
+            </a:pPr>
+            <a:r>
+              <a:rPr sz="1500" b="0">
+                <a:solidFill>
+                  <a:srgbClr val="10233B"/>
+                </a:solidFill>
+              </a:rPr>
+              <a:t>• Simulación y pronóstico mensual</a:t>
+            </a:r>
+          </a:p>
+          <a:p xmlns:a="http://schemas.openxmlformats.org/drawingml/2006/main">
+            <a:pPr algn="l">
+              <a:buNone/>
               <a:defRPr sz="1500" b="0">
                 <a:solidFill>
                   <a:srgbClr val="10233B"/>
@@ -3465,6 +3395,7 @@
           <a:lstStyle xmlns:a="http://schemas.openxmlformats.org/drawingml/2006/main"/>
           <a:p xmlns:a="http://schemas.openxmlformats.org/drawingml/2006/main">
             <a:pPr algn="l">
+              <a:buNone/>
               <a:defRPr sz="1275" b="1">
                 <a:solidFill>
                   <a:srgbClr val="37D5FF"/>
@@ -3515,6 +3446,7 @@
           <a:lstStyle xmlns:a="http://schemas.openxmlformats.org/drawingml/2006/main"/>
           <a:p xmlns:a="http://schemas.openxmlformats.org/drawingml/2006/main">
             <a:pPr algn="l">
+              <a:buNone/>
               <a:defRPr sz="1650" b="1">
                 <a:solidFill>
                   <a:srgbClr val="F7FBFF"/>
@@ -3527,7 +3459,7 @@
                   <a:srgbClr val="F7FBFF"/>
                 </a:solidFill>
               </a:rPr>
-              <a:t>Tomar decisiones en menos tiempo, con indicadores verificables y evidencia del documento.</a:t>
+              <a:t>Reducir el trabajo manual y comparar riesgos, liquidez y escenarios con resultados verificables.</a:t>
             </a:r>
           </a:p>
         </p:txBody>
@@ -3565,6 +3497,7 @@
           <a:lstStyle xmlns:a="http://schemas.openxmlformats.org/drawingml/2006/main"/>
           <a:p xmlns:a="http://schemas.openxmlformats.org/drawingml/2006/main">
             <a:pPr algn="l">
+              <a:buNone/>
               <a:defRPr sz="825" b="1">
                 <a:solidFill>
                   <a:srgbClr val="5B6F87"/>
@@ -3615,6 +3548,7 @@
           <a:lstStyle xmlns:a="http://schemas.openxmlformats.org/drawingml/2006/main"/>
           <a:p xmlns:a="http://schemas.openxmlformats.org/drawingml/2006/main">
             <a:pPr algn="r">
+              <a:buNone/>
               <a:defRPr sz="975" b="1">
                 <a:solidFill>
                   <a:srgbClr val="5B6F87"/>
@@ -3694,6 +3628,7 @@
           <a:lstStyle xmlns:a="http://schemas.openxmlformats.org/drawingml/2006/main"/>
           <a:p xmlns:a="http://schemas.openxmlformats.org/drawingml/2006/main">
             <a:pPr algn="l">
+              <a:buNone/>
               <a:defRPr sz="1200" b="1">
                 <a:solidFill>
                   <a:srgbClr val="37D5FF"/>
@@ -3744,6 +3679,7 @@
           <a:lstStyle xmlns:a="http://schemas.openxmlformats.org/drawingml/2006/main"/>
           <a:p xmlns:a="http://schemas.openxmlformats.org/drawingml/2006/main">
             <a:pPr algn="l">
+              <a:buNone/>
               <a:defRPr sz="2850" b="1">
                 <a:solidFill>
                   <a:srgbClr val="F7FBFF"/>
@@ -3825,6 +3761,7 @@
           <a:lstStyle xmlns:a="http://schemas.openxmlformats.org/drawingml/2006/main"/>
           <a:p xmlns:a="http://schemas.openxmlformats.org/drawingml/2006/main">
             <a:pPr algn="l">
+              <a:buNone/>
               <a:defRPr sz="1200" b="1">
                 <a:solidFill>
                   <a:srgbClr val="37D5FF"/>
@@ -3906,6 +3843,7 @@
           <a:lstStyle xmlns:a="http://schemas.openxmlformats.org/drawingml/2006/main"/>
           <a:p xmlns:a="http://schemas.openxmlformats.org/drawingml/2006/main">
             <a:pPr algn="l">
+              <a:buNone/>
               <a:defRPr sz="1575" b="1">
                 <a:solidFill>
                   <a:srgbClr val="F7FBFF"/>
@@ -3956,6 +3894,7 @@
           <a:lstStyle xmlns:a="http://schemas.openxmlformats.org/drawingml/2006/main"/>
           <a:p xmlns:a="http://schemas.openxmlformats.org/drawingml/2006/main">
             <a:pPr algn="l">
+              <a:buNone/>
               <a:defRPr sz="1200" b="0">
                 <a:solidFill>
                   <a:srgbClr val="AFC5DC"/>
@@ -4037,6 +3976,7 @@
           <a:lstStyle xmlns:a="http://schemas.openxmlformats.org/drawingml/2006/main"/>
           <a:p xmlns:a="http://schemas.openxmlformats.org/drawingml/2006/main">
             <a:pPr algn="l">
+              <a:buNone/>
               <a:defRPr sz="1575" b="1">
                 <a:solidFill>
                   <a:srgbClr val="F7FBFF"/>
@@ -4087,6 +4027,7 @@
           <a:lstStyle xmlns:a="http://schemas.openxmlformats.org/drawingml/2006/main"/>
           <a:p xmlns:a="http://schemas.openxmlformats.org/drawingml/2006/main">
             <a:pPr algn="l">
+              <a:buNone/>
               <a:defRPr sz="1200" b="0">
                 <a:solidFill>
                   <a:srgbClr val="AFC5DC"/>
@@ -4099,7 +4040,7 @@
                   <a:srgbClr val="AFC5DC"/>
                 </a:solidFill>
               </a:rPr>
-              <a:t>Gráficos interactivos</a:t>
+              <a:t>Dashboard y pronóstico interactivo</a:t>
             </a:r>
           </a:p>
         </p:txBody>
@@ -4168,6 +4109,7 @@
           <a:lstStyle xmlns:a="http://schemas.openxmlformats.org/drawingml/2006/main"/>
           <a:p xmlns:a="http://schemas.openxmlformats.org/drawingml/2006/main">
             <a:pPr algn="l">
+              <a:buNone/>
               <a:defRPr sz="1575" b="1">
                 <a:solidFill>
                   <a:srgbClr val="F7FBFF"/>
@@ -4218,6 +4160,7 @@
           <a:lstStyle xmlns:a="http://schemas.openxmlformats.org/drawingml/2006/main"/>
           <a:p xmlns:a="http://schemas.openxmlformats.org/drawingml/2006/main">
             <a:pPr algn="l">
+              <a:buNone/>
               <a:defRPr sz="1200" b="0">
                 <a:solidFill>
                   <a:srgbClr val="AFC5DC"/>
@@ -4299,6 +4242,7 @@
           <a:lstStyle xmlns:a="http://schemas.openxmlformats.org/drawingml/2006/main"/>
           <a:p xmlns:a="http://schemas.openxmlformats.org/drawingml/2006/main">
             <a:pPr algn="l">
+              <a:buNone/>
               <a:defRPr sz="1200" b="1">
                 <a:solidFill>
                   <a:srgbClr val="168BFF"/>
@@ -4380,6 +4324,7 @@
           <a:lstStyle xmlns:a="http://schemas.openxmlformats.org/drawingml/2006/main"/>
           <a:p xmlns:a="http://schemas.openxmlformats.org/drawingml/2006/main">
             <a:pPr algn="l">
+              <a:buNone/>
               <a:defRPr sz="1575" b="1">
                 <a:solidFill>
                   <a:srgbClr val="F7FBFF"/>
@@ -4430,6 +4375,7 @@
           <a:lstStyle xmlns:a="http://schemas.openxmlformats.org/drawingml/2006/main"/>
           <a:p xmlns:a="http://schemas.openxmlformats.org/drawingml/2006/main">
             <a:pPr algn="l">
+              <a:buNone/>
               <a:defRPr sz="1200" b="0">
                 <a:solidFill>
                   <a:srgbClr val="AFC5DC"/>
@@ -4511,6 +4457,7 @@
           <a:lstStyle xmlns:a="http://schemas.openxmlformats.org/drawingml/2006/main"/>
           <a:p xmlns:a="http://schemas.openxmlformats.org/drawingml/2006/main">
             <a:pPr algn="l">
+              <a:buNone/>
               <a:defRPr sz="1575" b="1">
                 <a:solidFill>
                   <a:srgbClr val="F7FBFF"/>
@@ -4561,6 +4508,7 @@
           <a:lstStyle xmlns:a="http://schemas.openxmlformats.org/drawingml/2006/main"/>
           <a:p xmlns:a="http://schemas.openxmlformats.org/drawingml/2006/main">
             <a:pPr algn="l">
+              <a:buNone/>
               <a:defRPr sz="1200" b="0">
                 <a:solidFill>
                   <a:srgbClr val="AFC5DC"/>
@@ -4642,6 +4590,7 @@
           <a:lstStyle xmlns:a="http://schemas.openxmlformats.org/drawingml/2006/main"/>
           <a:p xmlns:a="http://schemas.openxmlformats.org/drawingml/2006/main">
             <a:pPr algn="l">
+              <a:buNone/>
               <a:defRPr sz="1575" b="1">
                 <a:solidFill>
                   <a:srgbClr val="F7FBFF"/>
@@ -4692,6 +4641,7 @@
           <a:lstStyle xmlns:a="http://schemas.openxmlformats.org/drawingml/2006/main"/>
           <a:p xmlns:a="http://schemas.openxmlformats.org/drawingml/2006/main">
             <a:pPr algn="l">
+              <a:buNone/>
               <a:defRPr sz="1200" b="0">
                 <a:solidFill>
                   <a:srgbClr val="AFC5DC"/>
@@ -4704,7 +4654,7 @@
                   <a:srgbClr val="AFC5DC"/>
                 </a:solidFill>
               </a:rPr>
-              <a:t>OCR, extracción, RAG y resumen</a:t>
+              <a:t>OCR, extracción, RAG y explicación</a:t>
             </a:r>
           </a:p>
         </p:txBody>
@@ -4773,6 +4723,7 @@
           <a:lstStyle xmlns:a="http://schemas.openxmlformats.org/drawingml/2006/main"/>
           <a:p xmlns:a="http://schemas.openxmlformats.org/drawingml/2006/main">
             <a:pPr algn="l">
+              <a:buNone/>
               <a:defRPr sz="1575" b="1">
                 <a:solidFill>
                   <a:srgbClr val="F7FBFF"/>
@@ -4823,6 +4774,7 @@
           <a:lstStyle xmlns:a="http://schemas.openxmlformats.org/drawingml/2006/main"/>
           <a:p xmlns:a="http://schemas.openxmlformats.org/drawingml/2006/main">
             <a:pPr algn="l">
+              <a:buNone/>
               <a:defRPr sz="1200" b="0">
                 <a:solidFill>
                   <a:srgbClr val="AFC5DC"/>
@@ -4904,6 +4856,7 @@
           <a:lstStyle xmlns:a="http://schemas.openxmlformats.org/drawingml/2006/main"/>
           <a:p xmlns:a="http://schemas.openxmlformats.org/drawingml/2006/main">
             <a:pPr algn="l">
+              <a:buNone/>
               <a:defRPr sz="1200" b="1">
                 <a:solidFill>
                   <a:srgbClr val="26D99A"/>
@@ -4985,6 +4938,7 @@
           <a:lstStyle xmlns:a="http://schemas.openxmlformats.org/drawingml/2006/main"/>
           <a:p xmlns:a="http://schemas.openxmlformats.org/drawingml/2006/main">
             <a:pPr algn="l">
+              <a:buNone/>
               <a:defRPr sz="1575" b="1">
                 <a:solidFill>
                   <a:srgbClr val="F7FBFF"/>
@@ -5035,6 +4989,7 @@
           <a:lstStyle xmlns:a="http://schemas.openxmlformats.org/drawingml/2006/main"/>
           <a:p xmlns:a="http://schemas.openxmlformats.org/drawingml/2006/main">
             <a:pPr algn="l">
+              <a:buNone/>
               <a:defRPr sz="1200" b="0">
                 <a:solidFill>
                   <a:srgbClr val="AFC5DC"/>
@@ -5047,7 +5002,7 @@
                   <a:srgbClr val="AFC5DC"/>
                 </a:solidFill>
               </a:rPr>
-              <a:t>Trazas, tiempos y errores</a:t>
+              <a:t>Nodos, latencias y errores</a:t>
             </a:r>
           </a:p>
         </p:txBody>
@@ -5116,6 +5071,7 @@
           <a:lstStyle xmlns:a="http://schemas.openxmlformats.org/drawingml/2006/main"/>
           <a:p xmlns:a="http://schemas.openxmlformats.org/drawingml/2006/main">
             <a:pPr algn="l">
+              <a:buNone/>
               <a:defRPr sz="1575" b="1">
                 <a:solidFill>
                   <a:srgbClr val="F7FBFF"/>
@@ -5166,6 +5122,7 @@
           <a:lstStyle xmlns:a="http://schemas.openxmlformats.org/drawingml/2006/main"/>
           <a:p xmlns:a="http://schemas.openxmlformats.org/drawingml/2006/main">
             <a:pPr algn="l">
+              <a:buNone/>
               <a:defRPr sz="1200" b="0">
                 <a:solidFill>
                   <a:srgbClr val="AFC5DC"/>
@@ -5247,6 +5204,7 @@
           <a:lstStyle xmlns:a="http://schemas.openxmlformats.org/drawingml/2006/main"/>
           <a:p xmlns:a="http://schemas.openxmlformats.org/drawingml/2006/main">
             <a:pPr algn="l">
+              <a:buNone/>
               <a:defRPr sz="1575" b="1">
                 <a:solidFill>
                   <a:srgbClr val="F7FBFF"/>
@@ -5297,6 +5255,7 @@
           <a:lstStyle xmlns:a="http://schemas.openxmlformats.org/drawingml/2006/main"/>
           <a:p xmlns:a="http://schemas.openxmlformats.org/drawingml/2006/main">
             <a:pPr algn="l">
+              <a:buNone/>
               <a:defRPr sz="1200" b="0">
                 <a:solidFill>
                   <a:srgbClr val="AFC5DC"/>
@@ -5413,6 +5372,7 @@
           <a:lstStyle xmlns:a="http://schemas.openxmlformats.org/drawingml/2006/main"/>
           <a:p xmlns:a="http://schemas.openxmlformats.org/drawingml/2006/main">
             <a:pPr algn="ctr">
+              <a:buNone/>
               <a:defRPr sz="1425" b="1">
                 <a:solidFill>
                   <a:srgbClr val="F7FBFF"/>
@@ -5425,7 +5385,7 @@
                   <a:srgbClr val="F7FBFF"/>
                 </a:solidFill>
               </a:rPr>
-              <a:t>Python calcula los indicadores; Gemini extrae, interpreta y explica. La IA no sustituye el cálculo determinístico.</a:t>
+              <a:t>Python calcula ratios, simula inversiones y pronostica ventas; Gemini extrae, interpreta y explica.</a:t>
             </a:r>
           </a:p>
         </p:txBody>
@@ -5463,6 +5423,7 @@
           <a:lstStyle xmlns:a="http://schemas.openxmlformats.org/drawingml/2006/main"/>
           <a:p xmlns:a="http://schemas.openxmlformats.org/drawingml/2006/main">
             <a:pPr algn="l">
+              <a:buNone/>
               <a:defRPr sz="825" b="1">
                 <a:solidFill>
                   <a:srgbClr val="AFC5DC"/>
@@ -5513,6 +5474,7 @@
           <a:lstStyle xmlns:a="http://schemas.openxmlformats.org/drawingml/2006/main"/>
           <a:p xmlns:a="http://schemas.openxmlformats.org/drawingml/2006/main">
             <a:pPr algn="r">
+              <a:buNone/>
               <a:defRPr sz="975" b="1">
                 <a:solidFill>
                   <a:srgbClr val="AFC5DC"/>
@@ -5592,6 +5554,7 @@
           <a:lstStyle xmlns:a="http://schemas.openxmlformats.org/drawingml/2006/main"/>
           <a:p xmlns:a="http://schemas.openxmlformats.org/drawingml/2006/main">
             <a:pPr algn="l">
+              <a:buNone/>
               <a:defRPr sz="1200" b="1">
                 <a:solidFill>
                   <a:srgbClr val="168BFF"/>
@@ -5642,6 +5605,7 @@
           <a:lstStyle xmlns:a="http://schemas.openxmlformats.org/drawingml/2006/main"/>
           <a:p xmlns:a="http://schemas.openxmlformats.org/drawingml/2006/main">
             <a:pPr algn="l">
+              <a:buNone/>
               <a:defRPr sz="2850" b="1">
                 <a:solidFill>
                   <a:srgbClr val="10233B"/>
@@ -5654,7 +5618,7 @@
                   <a:srgbClr val="10233B"/>
                 </a:solidFill>
               </a:rPr>
-              <a:t>LangGraph convierte el análisis en un flujo controlado</a:t>
+              <a:t>LangGraph controla el flujo y MLflow observa cada ejecución</a:t>
             </a:r>
           </a:p>
         </p:txBody>
@@ -6109,6 +6073,7 @@
           <a:lstStyle xmlns:a="http://schemas.openxmlformats.org/drawingml/2006/main"/>
           <a:p xmlns:a="http://schemas.openxmlformats.org/drawingml/2006/main">
             <a:pPr algn="ctr">
+              <a:buNone/>
               <a:defRPr sz="1350" b="1">
                 <a:solidFill>
                   <a:srgbClr val="10233B"/>
@@ -6225,6 +6190,7 @@
           <a:lstStyle xmlns:a="http://schemas.openxmlformats.org/drawingml/2006/main"/>
           <a:p xmlns:a="http://schemas.openxmlformats.org/drawingml/2006/main">
             <a:pPr algn="ctr">
+              <a:buNone/>
               <a:defRPr sz="1350" b="1">
                 <a:solidFill>
                   <a:srgbClr val="10233B"/>
@@ -6341,6 +6307,7 @@
           <a:lstStyle xmlns:a="http://schemas.openxmlformats.org/drawingml/2006/main"/>
           <a:p xmlns:a="http://schemas.openxmlformats.org/drawingml/2006/main">
             <a:pPr algn="ctr">
+              <a:buNone/>
               <a:defRPr sz="1350" b="1">
                 <a:solidFill>
                   <a:srgbClr val="10233B"/>
@@ -6358,6 +6325,7 @@
           </a:p>
           <a:p xmlns:a="http://schemas.openxmlformats.org/drawingml/2006/main">
             <a:pPr algn="ctr">
+              <a:buNone/>
               <a:defRPr sz="1350" b="1">
                 <a:solidFill>
                   <a:srgbClr val="10233B"/>
@@ -6474,6 +6442,7 @@
           <a:lstStyle xmlns:a="http://schemas.openxmlformats.org/drawingml/2006/main"/>
           <a:p xmlns:a="http://schemas.openxmlformats.org/drawingml/2006/main">
             <a:pPr algn="ctr">
+              <a:buNone/>
               <a:defRPr sz="1350" b="1">
                 <a:solidFill>
                   <a:srgbClr val="10233B"/>
@@ -6491,6 +6460,7 @@
           </a:p>
           <a:p xmlns:a="http://schemas.openxmlformats.org/drawingml/2006/main">
             <a:pPr algn="ctr">
+              <a:buNone/>
               <a:defRPr sz="1350" b="1">
                 <a:solidFill>
                   <a:srgbClr val="10233B"/>
@@ -6607,6 +6577,7 @@
           <a:lstStyle xmlns:a="http://schemas.openxmlformats.org/drawingml/2006/main"/>
           <a:p xmlns:a="http://schemas.openxmlformats.org/drawingml/2006/main">
             <a:pPr algn="ctr">
+              <a:buNone/>
               <a:defRPr sz="1350" b="1">
                 <a:solidFill>
                   <a:srgbClr val="10233B"/>
@@ -6723,6 +6694,7 @@
           <a:lstStyle xmlns:a="http://schemas.openxmlformats.org/drawingml/2006/main"/>
           <a:p xmlns:a="http://schemas.openxmlformats.org/drawingml/2006/main">
             <a:pPr algn="ctr">
+              <a:buNone/>
               <a:defRPr sz="1350" b="1">
                 <a:solidFill>
                   <a:srgbClr val="10233B"/>
@@ -6773,6 +6745,7 @@
           <a:lstStyle xmlns:a="http://schemas.openxmlformats.org/drawingml/2006/main"/>
           <a:p xmlns:a="http://schemas.openxmlformats.org/drawingml/2006/main">
             <a:pPr algn="l">
+              <a:buNone/>
               <a:defRPr sz="1200" b="1">
                 <a:solidFill>
                   <a:srgbClr val="168BFF"/>
@@ -6887,6 +6860,7 @@
           <a:lstStyle xmlns:a="http://schemas.openxmlformats.org/drawingml/2006/main"/>
           <a:p xmlns:a="http://schemas.openxmlformats.org/drawingml/2006/main">
             <a:pPr algn="ctr">
+              <a:buNone/>
               <a:defRPr sz="1275" b="1">
                 <a:solidFill>
                   <a:srgbClr val="F7FBFF"/>
@@ -6937,6 +6911,7 @@
           <a:lstStyle xmlns:a="http://schemas.openxmlformats.org/drawingml/2006/main"/>
           <a:p xmlns:a="http://schemas.openxmlformats.org/drawingml/2006/main">
             <a:pPr algn="l">
+              <a:buNone/>
               <a:defRPr sz="1425" b="1">
                 <a:solidFill>
                   <a:srgbClr val="10233B"/>
@@ -6949,7 +6924,7 @@
                   <a:srgbClr val="10233B"/>
                 </a:solidFill>
               </a:rPr>
-              <a:t>Extraer PDF</a:t>
+              <a:t>Extraer PDF normal u OCR</a:t>
             </a:r>
           </a:p>
         </p:txBody>
@@ -7051,6 +7026,7 @@
           <a:lstStyle xmlns:a="http://schemas.openxmlformats.org/drawingml/2006/main"/>
           <a:p xmlns:a="http://schemas.openxmlformats.org/drawingml/2006/main">
             <a:pPr algn="ctr">
+              <a:buNone/>
               <a:defRPr sz="1275" b="1">
                 <a:solidFill>
                   <a:srgbClr val="F7FBFF"/>
@@ -7101,6 +7077,7 @@
           <a:lstStyle xmlns:a="http://schemas.openxmlformats.org/drawingml/2006/main"/>
           <a:p xmlns:a="http://schemas.openxmlformats.org/drawingml/2006/main">
             <a:pPr algn="l">
+              <a:buNone/>
               <a:defRPr sz="1425" b="1">
                 <a:solidFill>
                   <a:srgbClr val="10233B"/>
@@ -7113,7 +7090,7 @@
                   <a:srgbClr val="10233B"/>
                 </a:solidFill>
               </a:rPr>
-              <a:t>Calcular ratios</a:t>
+              <a:t>Calcular indicadores</a:t>
             </a:r>
           </a:p>
         </p:txBody>
@@ -7215,6 +7192,7 @@
           <a:lstStyle xmlns:a="http://schemas.openxmlformats.org/drawingml/2006/main"/>
           <a:p xmlns:a="http://schemas.openxmlformats.org/drawingml/2006/main">
             <a:pPr algn="ctr">
+              <a:buNone/>
               <a:defRPr sz="1275" b="1">
                 <a:solidFill>
                   <a:srgbClr val="F7FBFF"/>
@@ -7265,6 +7243,7 @@
           <a:lstStyle xmlns:a="http://schemas.openxmlformats.org/drawingml/2006/main"/>
           <a:p xmlns:a="http://schemas.openxmlformats.org/drawingml/2006/main">
             <a:pPr algn="l">
+              <a:buNone/>
               <a:defRPr sz="1425" b="1">
                 <a:solidFill>
                   <a:srgbClr val="10233B"/>
@@ -7379,6 +7358,7 @@
           <a:lstStyle xmlns:a="http://schemas.openxmlformats.org/drawingml/2006/main"/>
           <a:p xmlns:a="http://schemas.openxmlformats.org/drawingml/2006/main">
             <a:pPr algn="ctr">
+              <a:buNone/>
               <a:defRPr sz="1275" b="1">
                 <a:solidFill>
                   <a:srgbClr val="F7FBFF"/>
@@ -7429,6 +7409,7 @@
           <a:lstStyle xmlns:a="http://schemas.openxmlformats.org/drawingml/2006/main"/>
           <a:p xmlns:a="http://schemas.openxmlformats.org/drawingml/2006/main">
             <a:pPr algn="l">
+              <a:buNone/>
               <a:defRPr sz="1425" b="1">
                 <a:solidFill>
                   <a:srgbClr val="10233B"/>
@@ -7479,6 +7460,7 @@
           <a:lstStyle xmlns:a="http://schemas.openxmlformats.org/drawingml/2006/main"/>
           <a:p xmlns:a="http://schemas.openxmlformats.org/drawingml/2006/main">
             <a:pPr algn="l">
+              <a:buNone/>
               <a:defRPr sz="1200" b="1">
                 <a:solidFill>
                   <a:srgbClr val="26D99A"/>
@@ -7560,6 +7542,7 @@
           <a:lstStyle xmlns:a="http://schemas.openxmlformats.org/drawingml/2006/main"/>
           <a:p xmlns:a="http://schemas.openxmlformats.org/drawingml/2006/main">
             <a:pPr algn="l">
+              <a:buNone/>
               <a:defRPr sz="1350" b="1">
                 <a:solidFill>
                   <a:srgbClr val="10233B"/>
@@ -7645,6 +7628,7 @@
           <a:lstStyle xmlns:a="http://schemas.openxmlformats.org/drawingml/2006/main"/>
           <a:p xmlns:a="http://schemas.openxmlformats.org/drawingml/2006/main">
             <a:pPr algn="ctr">
+              <a:buNone/>
               <a:defRPr sz="1500" b="1">
                 <a:solidFill>
                   <a:srgbClr val="10233B"/>
@@ -7695,6 +7679,7 @@
           <a:lstStyle xmlns:a="http://schemas.openxmlformats.org/drawingml/2006/main"/>
           <a:p xmlns:a="http://schemas.openxmlformats.org/drawingml/2006/main">
             <a:pPr algn="ctr">
+              <a:buNone/>
               <a:defRPr sz="1125" b="1">
                 <a:solidFill>
                   <a:srgbClr val="5B6F87"/>
@@ -7745,6 +7730,7 @@
           <a:lstStyle xmlns:a="http://schemas.openxmlformats.org/drawingml/2006/main"/>
           <a:p xmlns:a="http://schemas.openxmlformats.org/drawingml/2006/main">
             <a:pPr algn="ctr">
+              <a:buNone/>
               <a:defRPr sz="1275" b="1">
                 <a:solidFill>
                   <a:srgbClr val="168BFF"/>
@@ -7757,7 +7743,7 @@
                   <a:srgbClr val="168BFF"/>
                 </a:solidFill>
               </a:rPr>
-              <a:t>TOP_K = 3   ·   umbral semántico = 0.55</a:t>
+              <a:t>TOP_K = 3   ·   umbral semántico = 0.55   ·   trazas MLflow</a:t>
             </a:r>
           </a:p>
         </p:txBody>
@@ -7828,6 +7814,7 @@
           <a:lstStyle xmlns:a="http://schemas.openxmlformats.org/drawingml/2006/main"/>
           <a:p xmlns:a="http://schemas.openxmlformats.org/drawingml/2006/main">
             <a:pPr algn="ctr">
+              <a:buNone/>
               <a:defRPr sz="1275" b="1">
                 <a:solidFill>
                   <a:srgbClr val="F7FBFF"/>
@@ -7840,7 +7827,7 @@
                   <a:srgbClr val="F7FBFF"/>
                 </a:solidFill>
               </a:rPr>
-              <a:t>Liquidez  ·  Prueba ácida  ·  Endeudamiento  ·  Cobertura  ·  Margen  ·  ROA/ROE  ·  VAN/TIR/Payback</a:t>
+              <a:t>Liquidez  ·  Efectivo disponible  ·  Flujo de caja  ·  VAN/TIR/Payback  ·  Pronóstico de ventas</a:t>
             </a:r>
           </a:p>
         </p:txBody>
@@ -7878,6 +7865,7 @@
           <a:lstStyle xmlns:a="http://schemas.openxmlformats.org/drawingml/2006/main"/>
           <a:p xmlns:a="http://schemas.openxmlformats.org/drawingml/2006/main">
             <a:pPr algn="l">
+              <a:buNone/>
               <a:defRPr sz="825" b="1">
                 <a:solidFill>
                   <a:srgbClr val="5B6F87"/>
@@ -7928,6 +7916,7 @@
           <a:lstStyle xmlns:a="http://schemas.openxmlformats.org/drawingml/2006/main"/>
           <a:p xmlns:a="http://schemas.openxmlformats.org/drawingml/2006/main">
             <a:pPr algn="r">
+              <a:buNone/>
               <a:defRPr sz="975" b="1">
                 <a:solidFill>
                   <a:srgbClr val="5B6F87"/>
@@ -8007,6 +7996,7 @@
           <a:lstStyle xmlns:a="http://schemas.openxmlformats.org/drawingml/2006/main"/>
           <a:p xmlns:a="http://schemas.openxmlformats.org/drawingml/2006/main">
             <a:pPr algn="l">
+              <a:buNone/>
               <a:defRPr sz="1200" b="1">
                 <a:solidFill>
                   <a:srgbClr val="168BFF"/>
@@ -8057,6 +8047,7 @@
           <a:lstStyle xmlns:a="http://schemas.openxmlformats.org/drawingml/2006/main"/>
           <a:p xmlns:a="http://schemas.openxmlformats.org/drawingml/2006/main">
             <a:pPr algn="l">
+              <a:buNone/>
               <a:defRPr sz="2850" b="1">
                 <a:solidFill>
                   <a:srgbClr val="10233B"/>
@@ -8069,7 +8060,7 @@
                   <a:srgbClr val="10233B"/>
                 </a:solidFill>
               </a:rPr>
-              <a:t>Una demo verificable, no un mockup</a:t>
+              <a:t>Capacidades verificadas en la aplicación</a:t>
             </a:r>
           </a:p>
         </p:txBody>
@@ -8204,6 +8195,7 @@
           <a:lstStyle xmlns:a="http://schemas.openxmlformats.org/drawingml/2006/main"/>
           <a:p xmlns:a="http://schemas.openxmlformats.org/drawingml/2006/main">
             <a:pPr algn="ctr">
+              <a:buNone/>
               <a:defRPr sz="2100" b="1">
                 <a:solidFill>
                   <a:srgbClr val="168BFF"/>
@@ -8216,7 +8208,7 @@
                   <a:srgbClr val="168BFF"/>
                 </a:solidFill>
               </a:rPr>
-              <a:t>▣</a:t>
+              <a:t/>
             </a:r>
           </a:p>
         </p:txBody>
@@ -8237,8 +8229,8 @@
         </p:nvSpPr>
         <p:spPr>
           <a:xfrm xmlns:a="http://schemas.openxmlformats.org/drawingml/2006/main">
-            <a:off x="819150" y="2652713"/>
-            <a:ext cx="2876550" cy="323850"/>
+            <a:off x="819150" y="3105150"/>
+            <a:ext cx="2876550" cy="266700"/>
           </a:xfrm>
           <a:prstGeom xmlns:a="http://schemas.openxmlformats.org/drawingml/2006/main" prst="rect">
             <a:avLst/>
@@ -8254,6 +8246,7 @@
           <a:lstStyle xmlns:a="http://schemas.openxmlformats.org/drawingml/2006/main"/>
           <a:p xmlns:a="http://schemas.openxmlformats.org/drawingml/2006/main">
             <a:pPr algn="ctr">
+              <a:buNone/>
               <a:defRPr sz="1200" b="1">
                 <a:solidFill>
                   <a:srgbClr val="5B6F87"/>
@@ -8266,7 +8259,7 @@
                   <a:srgbClr val="5B6F87"/>
                 </a:solidFill>
               </a:rPr>
-              <a:t>Análisis + alertas</a:t>
+              <a:t>Dashboard financiero mensual</a:t>
             </a:r>
           </a:p>
         </p:txBody>
@@ -8287,8 +8280,8 @@
         </p:nvSpPr>
         <p:spPr>
           <a:xfrm xmlns:a="http://schemas.openxmlformats.org/drawingml/2006/main">
-            <a:off x="819150" y="3267075"/>
-            <a:ext cx="2876550" cy="171450"/>
+            <a:off x="819150" y="3343275"/>
+            <a:ext cx="2876550" cy="152400"/>
           </a:xfrm>
           <a:prstGeom xmlns:a="http://schemas.openxmlformats.org/drawingml/2006/main" prst="rect">
             <a:avLst/>
@@ -8304,6 +8297,7 @@
           <a:lstStyle xmlns:a="http://schemas.openxmlformats.org/drawingml/2006/main"/>
           <a:p xmlns:a="http://schemas.openxmlformats.org/drawingml/2006/main">
             <a:pPr algn="ctr">
+              <a:buNone/>
               <a:defRPr sz="750" b="1">
                 <a:solidFill>
                   <a:srgbClr val="5B6F87"/>
@@ -8316,7 +8310,7 @@
                   <a:srgbClr val="5B6F87"/>
                 </a:solidFill>
               </a:rPr>
-              <a:t>REEMPLAZAR CON CAPTURA REAL</a:t>
+              <a:t>SERIES MENSUALES Y RATIOS</a:t>
             </a:r>
           </a:p>
         </p:txBody>
@@ -8420,6 +8414,7 @@
           <a:lstStyle xmlns:a="http://schemas.openxmlformats.org/drawingml/2006/main"/>
           <a:p xmlns:a="http://schemas.openxmlformats.org/drawingml/2006/main">
             <a:pPr algn="ctr">
+              <a:buNone/>
               <a:defRPr sz="2100" b="1">
                 <a:solidFill>
                   <a:srgbClr val="168BFF"/>
@@ -8432,7 +8427,7 @@
                   <a:srgbClr val="168BFF"/>
                 </a:solidFill>
               </a:rPr>
-              <a:t>▣</a:t>
+              <a:t/>
             </a:r>
           </a:p>
         </p:txBody>
@@ -8453,8 +8448,8 @@
         </p:nvSpPr>
         <p:spPr>
           <a:xfrm xmlns:a="http://schemas.openxmlformats.org/drawingml/2006/main">
-            <a:off x="4657725" y="2652713"/>
-            <a:ext cx="2876550" cy="323850"/>
+            <a:off x="4657725" y="3105150"/>
+            <a:ext cx="2876550" cy="266700"/>
           </a:xfrm>
           <a:prstGeom xmlns:a="http://schemas.openxmlformats.org/drawingml/2006/main" prst="rect">
             <a:avLst/>
@@ -8470,6 +8465,7 @@
           <a:lstStyle xmlns:a="http://schemas.openxmlformats.org/drawingml/2006/main"/>
           <a:p xmlns:a="http://schemas.openxmlformats.org/drawingml/2006/main">
             <a:pPr algn="ctr">
+              <a:buNone/>
               <a:defRPr sz="1200" b="1">
                 <a:solidFill>
                   <a:srgbClr val="5B6F87"/>
@@ -8482,7 +8478,7 @@
                   <a:srgbClr val="5B6F87"/>
                 </a:solidFill>
               </a:rPr>
-              <a:t>Dashboard interactivo</a:t>
+              <a:t>Pronóstico de 1 a 12 meses</a:t>
             </a:r>
           </a:p>
         </p:txBody>
@@ -8503,8 +8499,8 @@
         </p:nvSpPr>
         <p:spPr>
           <a:xfrm xmlns:a="http://schemas.openxmlformats.org/drawingml/2006/main">
-            <a:off x="4657725" y="3267075"/>
-            <a:ext cx="2876550" cy="171450"/>
+            <a:off x="4657725" y="3343275"/>
+            <a:ext cx="2876550" cy="152400"/>
           </a:xfrm>
           <a:prstGeom xmlns:a="http://schemas.openxmlformats.org/drawingml/2006/main" prst="rect">
             <a:avLst/>
@@ -8520,6 +8516,7 @@
           <a:lstStyle xmlns:a="http://schemas.openxmlformats.org/drawingml/2006/main"/>
           <a:p xmlns:a="http://schemas.openxmlformats.org/drawingml/2006/main">
             <a:pPr algn="ctr">
+              <a:buNone/>
               <a:defRPr sz="750" b="1">
                 <a:solidFill>
                   <a:srgbClr val="5B6F87"/>
@@ -8532,7 +8529,7 @@
                   <a:srgbClr val="5B6F87"/>
                 </a:solidFill>
               </a:rPr>
-              <a:t>REEMPLAZAR CON CAPTURA REAL</a:t>
+              <a:t>MODELO Y ERROR HISTÓRICO</a:t>
             </a:r>
           </a:p>
         </p:txBody>
@@ -8636,6 +8633,7 @@
           <a:lstStyle xmlns:a="http://schemas.openxmlformats.org/drawingml/2006/main"/>
           <a:p xmlns:a="http://schemas.openxmlformats.org/drawingml/2006/main">
             <a:pPr algn="ctr">
+              <a:buNone/>
               <a:defRPr sz="2100" b="1">
                 <a:solidFill>
                   <a:srgbClr val="168BFF"/>
@@ -8648,7 +8646,7 @@
                   <a:srgbClr val="168BFF"/>
                 </a:solidFill>
               </a:rPr>
-              <a:t>▣</a:t>
+              <a:t/>
             </a:r>
           </a:p>
         </p:txBody>
@@ -8669,8 +8667,8 @@
         </p:nvSpPr>
         <p:spPr>
           <a:xfrm xmlns:a="http://schemas.openxmlformats.org/drawingml/2006/main">
-            <a:off x="8496300" y="2652713"/>
-            <a:ext cx="2876550" cy="323850"/>
+            <a:off x="8496300" y="3105150"/>
+            <a:ext cx="2876550" cy="266700"/>
           </a:xfrm>
           <a:prstGeom xmlns:a="http://schemas.openxmlformats.org/drawingml/2006/main" prst="rect">
             <a:avLst/>
@@ -8686,6 +8684,7 @@
           <a:lstStyle xmlns:a="http://schemas.openxmlformats.org/drawingml/2006/main"/>
           <a:p xmlns:a="http://schemas.openxmlformats.org/drawingml/2006/main">
             <a:pPr algn="ctr">
+              <a:buNone/>
               <a:defRPr sz="1200" b="1">
                 <a:solidFill>
                   <a:srgbClr val="5B6F87"/>
@@ -8698,7 +8697,7 @@
                   <a:srgbClr val="5B6F87"/>
                 </a:solidFill>
               </a:rPr>
-              <a:t>Pregunta + evidencia</a:t>
+              <a:t>MLflow por ejecución y nodo</a:t>
             </a:r>
           </a:p>
         </p:txBody>
@@ -8719,8 +8718,8 @@
         </p:nvSpPr>
         <p:spPr>
           <a:xfrm xmlns:a="http://schemas.openxmlformats.org/drawingml/2006/main">
-            <a:off x="8496300" y="3267075"/>
-            <a:ext cx="2876550" cy="171450"/>
+            <a:off x="8496300" y="3343275"/>
+            <a:ext cx="2876550" cy="152400"/>
           </a:xfrm>
           <a:prstGeom xmlns:a="http://schemas.openxmlformats.org/drawingml/2006/main" prst="rect">
             <a:avLst/>
@@ -8736,6 +8735,7 @@
           <a:lstStyle xmlns:a="http://schemas.openxmlformats.org/drawingml/2006/main"/>
           <a:p xmlns:a="http://schemas.openxmlformats.org/drawingml/2006/main">
             <a:pPr algn="ctr">
+              <a:buNone/>
               <a:defRPr sz="750" b="1">
                 <a:solidFill>
                   <a:srgbClr val="5B6F87"/>
@@ -8748,7 +8748,7 @@
                   <a:srgbClr val="5B6F87"/>
                 </a:solidFill>
               </a:rPr>
-              <a:t>REEMPLAZAR CON CAPTURA REAL</a:t>
+              <a:t>LATENCIA, ESTADO Y CAMPOS</a:t>
             </a:r>
           </a:p>
         </p:txBody>
@@ -8786,6 +8786,7 @@
           <a:lstStyle xmlns:a="http://schemas.openxmlformats.org/drawingml/2006/main"/>
           <a:p xmlns:a="http://schemas.openxmlformats.org/drawingml/2006/main">
             <a:pPr algn="ctr">
+              <a:buNone/>
               <a:defRPr sz="975" b="1">
                 <a:solidFill>
                   <a:srgbClr val="168BFF"/>
@@ -8836,6 +8837,7 @@
           <a:lstStyle xmlns:a="http://schemas.openxmlformats.org/drawingml/2006/main"/>
           <a:p xmlns:a="http://schemas.openxmlformats.org/drawingml/2006/main">
             <a:pPr algn="l">
+              <a:buNone/>
               <a:defRPr sz="1275" b="1">
                 <a:solidFill>
                   <a:srgbClr val="26D99A"/>
@@ -8848,7 +8850,7 @@
                   <a:srgbClr val="26D99A"/>
                 </a:solidFill>
               </a:rPr>
-              <a:t>IMPACTO</a:t>
+              <a:t>ANÁLISIS Y RAG</a:t>
             </a:r>
           </a:p>
         </p:txBody>
@@ -8886,6 +8888,7 @@
           <a:lstStyle xmlns:a="http://schemas.openxmlformats.org/drawingml/2006/main"/>
           <a:p xmlns:a="http://schemas.openxmlformats.org/drawingml/2006/main">
             <a:pPr algn="l">
+              <a:buNone/>
               <a:defRPr sz="1350" b="0">
                 <a:solidFill>
                   <a:srgbClr val="10233B"/>
@@ -8898,11 +8901,12 @@
                   <a:srgbClr val="10233B"/>
                 </a:solidFill>
               </a:rPr>
-              <a:t>• Automatiza ratios y alertas</a:t>
+              <a:t>Ratios y alertas automáticas</a:t>
             </a:r>
           </a:p>
           <a:p xmlns:a="http://schemas.openxmlformats.org/drawingml/2006/main">
             <a:pPr algn="l">
+              <a:buNone/>
               <a:defRPr sz="1350" b="0">
                 <a:solidFill>
                   <a:srgbClr val="10233B"/>
@@ -8915,11 +8919,12 @@
                   <a:srgbClr val="10233B"/>
                 </a:solidFill>
               </a:rPr>
-              <a:t>• Responde con evidencia</a:t>
+              <a:t>RAG graduado con evidencia</a:t>
             </a:r>
           </a:p>
           <a:p xmlns:a="http://schemas.openxmlformats.org/drawingml/2006/main">
             <a:pPr algn="l">
+              <a:buNone/>
               <a:defRPr sz="1350" b="0">
                 <a:solidFill>
                   <a:srgbClr val="10233B"/>
@@ -8932,11 +8937,12 @@
                   <a:srgbClr val="10233B"/>
                 </a:solidFill>
               </a:rPr>
-              <a:t>• Exporta PDF y CSV</a:t>
+              <a:t>Extracción normal u OCR</a:t>
             </a:r>
           </a:p>
           <a:p xmlns:a="http://schemas.openxmlformats.org/drawingml/2006/main">
             <a:pPr algn="l">
+              <a:buNone/>
               <a:defRPr sz="1350" b="0">
                 <a:solidFill>
                   <a:srgbClr val="10233B"/>
@@ -8949,7 +8955,7 @@
                   <a:srgbClr val="10233B"/>
                 </a:solidFill>
               </a:rPr>
-              <a:t>• Protege el acceso por roles</a:t>
+              <a:t>Guardrails y control humano</a:t>
             </a:r>
           </a:p>
         </p:txBody>
@@ -9018,6 +9024,7 @@
           <a:lstStyle xmlns:a="http://schemas.openxmlformats.org/drawingml/2006/main"/>
           <a:p xmlns:a="http://schemas.openxmlformats.org/drawingml/2006/main">
             <a:pPr algn="l">
+              <a:buNone/>
               <a:defRPr sz="1275" b="1">
                 <a:solidFill>
                   <a:srgbClr val="168BFF"/>
@@ -9030,7 +9037,7 @@
                   <a:srgbClr val="168BFF"/>
                 </a:solidFill>
               </a:rPr>
-              <a:t>APRENDIZAJES</a:t>
+              <a:t>PLANIFICACIÓN</a:t>
             </a:r>
           </a:p>
         </p:txBody>
@@ -9068,6 +9075,7 @@
           <a:lstStyle xmlns:a="http://schemas.openxmlformats.org/drawingml/2006/main"/>
           <a:p xmlns:a="http://schemas.openxmlformats.org/drawingml/2006/main">
             <a:pPr algn="l">
+              <a:buNone/>
               <a:defRPr sz="1350" b="0">
                 <a:solidFill>
                   <a:srgbClr val="10233B"/>
@@ -9080,11 +9088,12 @@
                   <a:srgbClr val="10233B"/>
                 </a:solidFill>
               </a:rPr>
-              <a:t>Cálculos separados de la IA</a:t>
+              <a:t>Efectivo y flujo de caja</a:t>
             </a:r>
           </a:p>
           <a:p xmlns:a="http://schemas.openxmlformats.org/drawingml/2006/main">
             <a:pPr algn="l">
+              <a:buNone/>
               <a:defRPr sz="1350" b="0">
                 <a:solidFill>
                   <a:srgbClr val="10233B"/>
@@ -9097,11 +9106,12 @@
                   <a:srgbClr val="10233B"/>
                 </a:solidFill>
               </a:rPr>
-              <a:t>RAG para reducir alucinaciones</a:t>
+              <a:t>VAN, TIR y recuperación</a:t>
             </a:r>
           </a:p>
           <a:p xmlns:a="http://schemas.openxmlformats.org/drawingml/2006/main">
             <a:pPr algn="l">
+              <a:buNone/>
               <a:defRPr sz="1350" b="0">
                 <a:solidFill>
                   <a:srgbClr val="10233B"/>
@@ -9114,7 +9124,25 @@
                   <a:srgbClr val="10233B"/>
                 </a:solidFill>
               </a:rPr>
-              <a:t>LangGraph para controlar el flujo</a:t>
+              <a:t>Conversión de tasas y capitalización</a:t>
+            </a:r>
+          </a:p>
+          <a:p xmlns:a="http://schemas.openxmlformats.org/drawingml/2006/main">
+            <a:pPr algn="l">
+              <a:buNone/>
+              <a:defRPr sz="1350" b="0">
+                <a:solidFill>
+                  <a:srgbClr val="10233B"/>
+                </a:solidFill>
+              </a:defRPr>
+            </a:pPr>
+            <a:r>
+              <a:rPr sz="1350" b="0">
+                <a:solidFill>
+                  <a:srgbClr val="10233B"/>
+                </a:solidFill>
+              </a:rPr>
+              <a:t>Pronóstico mensual con MAE</a:t>
             </a:r>
           </a:p>
         </p:txBody>
@@ -9183,6 +9211,7 @@
           <a:lstStyle xmlns:a="http://schemas.openxmlformats.org/drawingml/2006/main"/>
           <a:p xmlns:a="http://schemas.openxmlformats.org/drawingml/2006/main">
             <a:pPr algn="l">
+              <a:buNone/>
               <a:defRPr sz="1275" b="1">
                 <a:solidFill>
                   <a:srgbClr val="FFC857"/>
@@ -9195,7 +9224,7 @@
                   <a:srgbClr val="FFC857"/>
                 </a:solidFill>
               </a:rPr>
-              <a:t>SIGUIENTE PASO</a:t>
+              <a:t>CONTROL Y ENTREGA</a:t>
             </a:r>
           </a:p>
         </p:txBody>
@@ -9233,6 +9262,7 @@
           <a:lstStyle xmlns:a="http://schemas.openxmlformats.org/drawingml/2006/main"/>
           <a:p xmlns:a="http://schemas.openxmlformats.org/drawingml/2006/main">
             <a:pPr algn="l">
+              <a:buNone/>
               <a:defRPr sz="1350" b="0">
                 <a:solidFill>
                   <a:srgbClr val="10233B"/>
@@ -9245,7 +9275,61 @@
                   <a:srgbClr val="10233B"/>
                 </a:solidFill>
               </a:rPr>
-              <a:t>Comparación histórica, contingencias desde notas y PostgreSQL para mayor escala.</a:t>
+              <a:t>JWT, bcrypt y roles</a:t>
+            </a:r>
+          </a:p>
+          <a:p xmlns:a="http://schemas.openxmlformats.org/drawingml/2006/main">
+            <a:pPr algn="l">
+              <a:buNone/>
+              <a:defRPr sz="1350" b="0">
+                <a:solidFill>
+                  <a:srgbClr val="10233B"/>
+                </a:solidFill>
+              </a:defRPr>
+            </a:pPr>
+            <a:r>
+              <a:rPr sz="1350" b="0">
+                <a:solidFill>
+                  <a:srgbClr val="10233B"/>
+                </a:solidFill>
+              </a:rPr>
+              <a:t>Exportación PDF y CSV</a:t>
+            </a:r>
+          </a:p>
+          <a:p xmlns:a="http://schemas.openxmlformats.org/drawingml/2006/main">
+            <a:pPr algn="l">
+              <a:buNone/>
+              <a:defRPr sz="1350" b="0">
+                <a:solidFill>
+                  <a:srgbClr val="10233B"/>
+                </a:solidFill>
+              </a:defRPr>
+            </a:pPr>
+            <a:r>
+              <a:rPr sz="1350" b="0">
+                <a:solidFill>
+                  <a:srgbClr val="10233B"/>
+                </a:solidFill>
+              </a:rPr>
+              <a:t>Envío mediante Gmail API</a:t>
+            </a:r>
+          </a:p>
+          <a:p xmlns:a="http://schemas.openxmlformats.org/drawingml/2006/main">
+            <a:pPr algn="l">
+              <a:buNone/>
+              <a:defRPr sz="1350" b="0">
+                <a:solidFill>
+                  <a:srgbClr val="10233B"/>
+                </a:solidFill>
+              </a:defRPr>
+            </a:pPr>
+            <a:r>
+              <a:rPr sz="1350" b="0">
+                <a:solidFill>
+                  <a:srgbClr val="10233B"/>
+                </a:solidFill>
+              </a:rPr>
+              <a:t>Latencia por nodo en MLflow</a:t>
             </a:r>
           </a:p>
         </p:txBody>
@@ -9316,6 +9400,7 @@
           <a:lstStyle xmlns:a="http://schemas.openxmlformats.org/drawingml/2006/main"/>
           <a:p xmlns:a="http://schemas.openxmlformats.org/drawingml/2006/main">
             <a:pPr algn="ctr">
+              <a:buNone/>
               <a:defRPr sz="1500" b="1">
                 <a:solidFill>
                   <a:srgbClr val="F7FBFF"/>
@@ -9328,7 +9413,7 @@
                   <a:srgbClr val="F7FBFF"/>
                 </a:solidFill>
               </a:rPr>
-              <a:t>Información financiera comprensible, verificable y útil para decidir.</a:t>
+              <a:t>Análisis, proyección y trazabilidad reunidos en una aplicación financiera explicable.</a:t>
             </a:r>
           </a:p>
         </p:txBody>
@@ -9366,6 +9451,7 @@
           <a:lstStyle xmlns:a="http://schemas.openxmlformats.org/drawingml/2006/main"/>
           <a:p xmlns:a="http://schemas.openxmlformats.org/drawingml/2006/main">
             <a:pPr algn="l">
+              <a:buNone/>
               <a:defRPr sz="825" b="1">
                 <a:solidFill>
                   <a:srgbClr val="5B6F87"/>
@@ -9416,6 +9502,7 @@
           <a:lstStyle xmlns:a="http://schemas.openxmlformats.org/drawingml/2006/main"/>
           <a:p xmlns:a="http://schemas.openxmlformats.org/drawingml/2006/main">
             <a:pPr algn="r">
+              <a:buNone/>
               <a:defRPr sz="975" b="1">
                 <a:solidFill>
                   <a:srgbClr val="5B6F87"/>
@@ -9433,6 +9520,87 @@
           </a:p>
         </p:txBody>
       </p:sp>
+      <p:pic>
+        <p:nvPicPr>
+          <p:cNvPr id="67" name=""/>
+          <p:cNvPicPr>
+            <a:picLocks xmlns:a="http://schemas.openxmlformats.org/drawingml/2006/main" noChangeAspect="1"/>
+          </p:cNvPicPr>
+          <p:nvPr/>
+        </p:nvPicPr>
+        <p:blipFill>
+          <a:blip xmlns:r="http://schemas.openxmlformats.org/officeDocument/2006/relationships" xmlns:a="http://schemas.openxmlformats.org/drawingml/2006/main" r:embed="Rc13863f2fd4d411e"/>
+          <a:srcRect xmlns:a="http://schemas.openxmlformats.org/drawingml/2006/main" l="0" t="4083" r="0" b="4083"/>
+          <a:stretch xmlns:a="http://schemas.openxmlformats.org/drawingml/2006/main">
+            <a:fillRect l="0" t="0" r="0" b="0"/>
+          </a:stretch>
+        </p:blipFill>
+        <p:spPr>
+          <a:xfrm xmlns:a="http://schemas.openxmlformats.org/drawingml/2006/main">
+            <a:off x="781050" y="1762125"/>
+            <a:ext cx="2952750" cy="1285875"/>
+          </a:xfrm>
+          <a:prstGeom xmlns:a="http://schemas.openxmlformats.org/drawingml/2006/main" prst="roundRect">
+            <a:avLst>
+              <a:gd name="adj" fmla="val 5926"/>
+            </a:avLst>
+          </a:prstGeom>
+        </p:spPr>
+      </p:pic>
+      <p:pic>
+        <p:nvPicPr>
+          <p:cNvPr id="68" name=""/>
+          <p:cNvPicPr>
+            <a:picLocks xmlns:a="http://schemas.openxmlformats.org/drawingml/2006/main" noChangeAspect="1"/>
+          </p:cNvPicPr>
+          <p:nvPr/>
+        </p:nvPicPr>
+        <p:blipFill>
+          <a:blip xmlns:r="http://schemas.openxmlformats.org/officeDocument/2006/relationships" xmlns:a="http://schemas.openxmlformats.org/drawingml/2006/main" r:embed="Raf306f99c94e40a3"/>
+          <a:srcRect xmlns:a="http://schemas.openxmlformats.org/drawingml/2006/main" l="0" t="8731" r="0" b="8731"/>
+          <a:stretch xmlns:a="http://schemas.openxmlformats.org/drawingml/2006/main">
+            <a:fillRect l="0" t="0" r="0" b="0"/>
+          </a:stretch>
+        </p:blipFill>
+        <p:spPr>
+          <a:xfrm xmlns:a="http://schemas.openxmlformats.org/drawingml/2006/main">
+            <a:off x="4619625" y="1762125"/>
+            <a:ext cx="2952750" cy="1285875"/>
+          </a:xfrm>
+          <a:prstGeom xmlns:a="http://schemas.openxmlformats.org/drawingml/2006/main" prst="roundRect">
+            <a:avLst>
+              <a:gd name="adj" fmla="val 5926"/>
+            </a:avLst>
+          </a:prstGeom>
+        </p:spPr>
+      </p:pic>
+      <p:pic>
+        <p:nvPicPr>
+          <p:cNvPr id="69" name=""/>
+          <p:cNvPicPr>
+            <a:picLocks xmlns:a="http://schemas.openxmlformats.org/drawingml/2006/main" noChangeAspect="1"/>
+          </p:cNvPicPr>
+          <p:nvPr/>
+        </p:nvPicPr>
+        <p:blipFill>
+          <a:blip xmlns:r="http://schemas.openxmlformats.org/officeDocument/2006/relationships" xmlns:a="http://schemas.openxmlformats.org/drawingml/2006/main" r:embed="R25d364500cc041d6"/>
+          <a:srcRect xmlns:a="http://schemas.openxmlformats.org/drawingml/2006/main" l="0" t="3261" r="0" b="3261"/>
+          <a:stretch xmlns:a="http://schemas.openxmlformats.org/drawingml/2006/main">
+            <a:fillRect l="0" t="0" r="0" b="0"/>
+          </a:stretch>
+        </p:blipFill>
+        <p:spPr>
+          <a:xfrm xmlns:a="http://schemas.openxmlformats.org/drawingml/2006/main">
+            <a:off x="8458200" y="1762125"/>
+            <a:ext cx="2952750" cy="1285875"/>
+          </a:xfrm>
+          <a:prstGeom xmlns:a="http://schemas.openxmlformats.org/drawingml/2006/main" prst="roundRect">
+            <a:avLst>
+              <a:gd name="adj" fmla="val 5926"/>
+            </a:avLst>
+          </a:prstGeom>
+        </p:spPr>
+      </p:pic>
     </p:spTree>
     <p:extLst>
       <p:ext uri="{BB962C8B-B14F-4D97-AF65-F5344CB8AC3E}">

</xml_diff>